<commit_message>
Update presentation with actual app screenshots
</commit_message>
<xml_diff>
--- a/SchemeBot_Presentation.pptx
+++ b/SchemeBot_Presentation.pptx
@@ -3487,46 +3487,35 @@
           <a:lstStyle/>
           <a:p>
             <a:r>
-              <a:t>Demo: Initial Conversational Prompt</a:t>
-            </a:r>
-          </a:p>
-        </p:txBody>
-      </p:sp>
-      <p:sp>
-        <p:nvSpPr>
-          <p:cNvPr id="3" name="TextBox 2"/>
-          <p:cNvSpPr txBox="1"/>
+              <a:t>Demo: Initial Chat Interface</a:t>
+            </a:r>
+          </a:p>
+        </p:txBody>
+      </p:sp>
+      <p:pic>
+        <p:nvPicPr>
+          <p:cNvPr id="3" name="Picture 2" descr="media_1788927652030.png"/>
+          <p:cNvPicPr>
+            <a:picLocks noChangeAspect="1"/>
+          </p:cNvPicPr>
           <p:nvPr/>
-        </p:nvSpPr>
+        </p:nvPicPr>
+        <p:blipFill>
+          <a:blip r:embed="rId2"/>
+          <a:stretch>
+            <a:fillRect/>
+          </a:stretch>
+        </p:blipFill>
         <p:spPr>
           <a:xfrm>
-            <a:off x="1828800" y="2743200"/>
-            <a:ext cx="5486400" cy="1828800"/>
+            <a:off x="914400" y="1371600"/>
+            <a:ext cx="7315200" cy="3893344"/>
           </a:xfrm>
           <a:prstGeom prst="rect">
             <a:avLst/>
           </a:prstGeom>
-          <a:noFill/>
         </p:spPr>
-        <p:txBody>
-          <a:bodyPr wrap="none">
-            <a:spAutoFit/>
-          </a:bodyPr>
-          <a:lstStyle/>
-          <a:p>
-            <a:pPr>
-              <a:defRPr>
-                <a:solidFill>
-                  <a:srgbClr val="FF0000"/>
-                </a:solidFill>
-              </a:defRPr>
-            </a:pPr>
-            <a:r>
-              <a:t>[ INSERT SCREENSHOT OF INITIAL CHAT HERE ]</a:t>
-            </a:r>
-          </a:p>
-        </p:txBody>
-      </p:sp>
+      </p:pic>
     </p:spTree>
   </p:cSld>
   <p:clrMapOvr>
@@ -3561,46 +3550,35 @@
           <a:lstStyle/>
           <a:p>
             <a:r>
-              <a:t>Demo: Step-by-Step Questions</a:t>
-            </a:r>
-          </a:p>
-        </p:txBody>
-      </p:sp>
-      <p:sp>
-        <p:nvSpPr>
-          <p:cNvPr id="3" name="TextBox 2"/>
-          <p:cNvSpPr txBox="1"/>
+              <a:t>Demo: Conversational Interaction</a:t>
+            </a:r>
+          </a:p>
+        </p:txBody>
+      </p:sp>
+      <p:pic>
+        <p:nvPicPr>
+          <p:cNvPr id="3" name="Picture 2" descr="media_1788927671251.png"/>
+          <p:cNvPicPr>
+            <a:picLocks noChangeAspect="1"/>
+          </p:cNvPicPr>
           <p:nvPr/>
-        </p:nvSpPr>
+        </p:nvPicPr>
+        <p:blipFill>
+          <a:blip r:embed="rId2"/>
+          <a:stretch>
+            <a:fillRect/>
+          </a:stretch>
+        </p:blipFill>
         <p:spPr>
           <a:xfrm>
-            <a:off x="1828800" y="2743200"/>
-            <a:ext cx="5486400" cy="1828800"/>
+            <a:off x="914400" y="1371600"/>
+            <a:ext cx="7315200" cy="3414712"/>
           </a:xfrm>
           <a:prstGeom prst="rect">
             <a:avLst/>
           </a:prstGeom>
-          <a:noFill/>
         </p:spPr>
-        <p:txBody>
-          <a:bodyPr wrap="none">
-            <a:spAutoFit/>
-          </a:bodyPr>
-          <a:lstStyle/>
-          <a:p>
-            <a:pPr>
-              <a:defRPr>
-                <a:solidFill>
-                  <a:srgbClr val="FF0000"/>
-                </a:solidFill>
-              </a:defRPr>
-            </a:pPr>
-            <a:r>
-              <a:t>[ INSERT SCREENSHOT OF BOT ASKING GENDER/AGE HERE ]</a:t>
-            </a:r>
-          </a:p>
-        </p:txBody>
-      </p:sp>
+      </p:pic>
     </p:spTree>
   </p:cSld>
   <p:clrMapOvr>
@@ -3640,41 +3618,30 @@
           </a:p>
         </p:txBody>
       </p:sp>
-      <p:sp>
-        <p:nvSpPr>
-          <p:cNvPr id="3" name="TextBox 2"/>
-          <p:cNvSpPr txBox="1"/>
+      <p:pic>
+        <p:nvPicPr>
+          <p:cNvPr id="3" name="Picture 2" descr="media_1788927703788.png"/>
+          <p:cNvPicPr>
+            <a:picLocks noChangeAspect="1"/>
+          </p:cNvPicPr>
           <p:nvPr/>
-        </p:nvSpPr>
+        </p:nvPicPr>
+        <p:blipFill>
+          <a:blip r:embed="rId2"/>
+          <a:stretch>
+            <a:fillRect/>
+          </a:stretch>
+        </p:blipFill>
         <p:spPr>
           <a:xfrm>
-            <a:off x="1828800" y="2743200"/>
-            <a:ext cx="5486400" cy="1828800"/>
+            <a:off x="914400" y="1371600"/>
+            <a:ext cx="7315200" cy="3343275"/>
           </a:xfrm>
           <a:prstGeom prst="rect">
             <a:avLst/>
           </a:prstGeom>
-          <a:noFill/>
         </p:spPr>
-        <p:txBody>
-          <a:bodyPr wrap="none">
-            <a:spAutoFit/>
-          </a:bodyPr>
-          <a:lstStyle/>
-          <a:p>
-            <a:pPr>
-              <a:defRPr>
-                <a:solidFill>
-                  <a:srgbClr val="FF0000"/>
-                </a:solidFill>
-              </a:defRPr>
-            </a:pPr>
-            <a:r>
-              <a:t>[ INSERT SCREENSHOT OF SCHEME RESULTS FROM GOV API HERE ]</a:t>
-            </a:r>
-          </a:p>
-        </p:txBody>
-      </p:sp>
+      </p:pic>
     </p:spTree>
   </p:cSld>
   <p:clrMapOvr>

</xml_diff>